<commit_message>
World Teachers' Day: three new 2-slide options (group photo, drawn bunting, face wreath); no AI art or paper flowers
Co-Authored-By: Claude Opus 5.5 <noreply@anthropic.com>
Claude-Session: https://claude.ai/code/session_014HGzAbxBh54nuyJHG7tse8
</commit_message>
<xml_diff>
--- a/templates/posts/october/05-10-2026-mon-ig-teachers-day-A-pairs.pptx
+++ b/templates/posts/october/05-10-2026-mon-ig-teachers-day-A-pairs.pptx
@@ -4072,7 +4072,7 @@
     <p:bg>
       <p:bgPr>
         <a:solidFill>
-          <a:srgbClr val="31662F"/>
+          <a:srgbClr val="F3F1EA"/>
         </a:solidFill>
         <a:effectLst/>
       </p:bgPr>
@@ -4114,7 +4114,7 @@
             <a:r>
               <a:rPr sz="2000" b="1" i="0" spc="300">
                 <a:solidFill>
-                  <a:srgbClr val="B1BCB1"/>
+                  <a:srgbClr val="31662F"/>
                 </a:solidFill>
                 <a:latin typeface="Montserrat"/>
               </a:rPr>
@@ -4153,7 +4153,7 @@
             <a:r>
               <a:rPr sz="7600" b="1" i="0">
                 <a:solidFill>
-                  <a:srgbClr val="F3F1EA"/>
+                  <a:srgbClr val="31662F"/>
                 </a:solidFill>
                 <a:latin typeface="Montserrat"/>
               </a:rPr>
@@ -4192,7 +4192,7 @@
             <a:r>
               <a:rPr sz="3600" b="0" i="1">
                 <a:solidFill>
-                  <a:srgbClr val="F3F1EA"/>
+                  <a:srgbClr val="1A1A1A"/>
                 </a:solidFill>
                 <a:latin typeface="EB Garamond"/>
               </a:rPr>
@@ -4323,7 +4323,7 @@
       </p:pic>
       <p:pic>
         <p:nvPicPr>
-          <p:cNvPr id="10" name="Picture 9" descr="foundation-logo-white.png"/>
+          <p:cNvPr id="10" name="Picture 9" descr="foundation-logo-color.png"/>
           <p:cNvPicPr>
             <a:picLocks noChangeAspect="1"/>
           </p:cNvPicPr>
@@ -4373,7 +4373,7 @@
       <p:grpSpPr/>
       <p:pic>
         <p:nvPicPr>
-          <p:cNvPr id="2" name="Picture 1" descr="347519182137807568.jpg"/>
+          <p:cNvPr id="2" name="Picture 1" descr="3993400412155518647.jpg"/>
           <p:cNvPicPr>
             <a:picLocks noChangeAspect="1"/>
           </p:cNvPicPr>
@@ -4475,7 +4475,7 @@
       </p:sp>
       <p:pic>
         <p:nvPicPr>
-          <p:cNvPr id="5" name="Picture 4" descr="3538868740662328279.jpg"/>
+          <p:cNvPr id="5" name="Picture 4" descr="4588910110491757452.jpg"/>
           <p:cNvPicPr>
             <a:picLocks noChangeAspect="1"/>
           </p:cNvPicPr>
@@ -4686,7 +4686,7 @@
       <p:grpSpPr/>
       <p:pic>
         <p:nvPicPr>
-          <p:cNvPr id="2" name="Picture 1" descr="4153874960349894340.jpg"/>
+          <p:cNvPr id="2" name="Picture 1" descr="7773454019178611130.jpg"/>
           <p:cNvPicPr>
             <a:picLocks noChangeAspect="1"/>
           </p:cNvPicPr>
@@ -4866,7 +4866,7 @@
       </p:sp>
       <p:pic>
         <p:nvPicPr>
-          <p:cNvPr id="7" name="Picture 6" descr="3949146908296391229.jpg"/>
+          <p:cNvPr id="7" name="Picture 6" descr="7346929664015040449.jpg"/>
           <p:cNvPicPr>
             <a:picLocks noChangeAspect="1"/>
           </p:cNvPicPr>
@@ -5155,7 +5155,7 @@
       <p:grpSpPr/>
       <p:pic>
         <p:nvPicPr>
-          <p:cNvPr id="2" name="Picture 1" descr="7316900254035815973.jpg"/>
+          <p:cNvPr id="2" name="Picture 1" descr="273560057319620862.jpg"/>
           <p:cNvPicPr>
             <a:picLocks noChangeAspect="1"/>
           </p:cNvPicPr>
@@ -5296,7 +5296,7 @@
       </p:sp>
       <p:pic>
         <p:nvPicPr>
-          <p:cNvPr id="6" name="Picture 5" descr="931937063702372120.jpg"/>
+          <p:cNvPr id="6" name="Picture 5" descr="5252440024707173470.jpg"/>
           <p:cNvPicPr>
             <a:picLocks noChangeAspect="1"/>
           </p:cNvPicPr>
@@ -5546,7 +5546,7 @@
       <p:grpSpPr/>
       <p:pic>
         <p:nvPicPr>
-          <p:cNvPr id="2" name="Picture 1" descr="8276313903483008773.jpg"/>
+          <p:cNvPr id="2" name="Picture 1" descr="6097074925447576776.jpg"/>
           <p:cNvPicPr>
             <a:picLocks noChangeAspect="1"/>
           </p:cNvPicPr>
@@ -5687,7 +5687,7 @@
       </p:sp>
       <p:pic>
         <p:nvPicPr>
-          <p:cNvPr id="6" name="Picture 5" descr="2098973951563240289.jpg"/>
+          <p:cNvPr id="6" name="Picture 5" descr="4328774294215114109.jpg"/>
           <p:cNvPicPr>
             <a:picLocks noChangeAspect="1"/>
           </p:cNvPicPr>
@@ -5937,7 +5937,7 @@
       <p:grpSpPr/>
       <p:pic>
         <p:nvPicPr>
-          <p:cNvPr id="2" name="Picture 1" descr="8824606572028125773.jpg"/>
+          <p:cNvPr id="2" name="Picture 1" descr="2030329765136028633.jpg"/>
           <p:cNvPicPr>
             <a:picLocks noChangeAspect="1"/>
           </p:cNvPicPr>
@@ -6039,7 +6039,7 @@
       </p:sp>
       <p:pic>
         <p:nvPicPr>
-          <p:cNvPr id="5" name="Picture 4" descr="3167329764137955094.jpg"/>
+          <p:cNvPr id="5" name="Picture 4" descr="8534486798859622214.jpg"/>
           <p:cNvPicPr>
             <a:picLocks noChangeAspect="1"/>
           </p:cNvPicPr>
@@ -6328,7 +6328,7 @@
       <p:grpSpPr/>
       <p:pic>
         <p:nvPicPr>
-          <p:cNvPr id="2" name="Picture 1" descr="4850999657177376917.jpg"/>
+          <p:cNvPr id="2" name="Picture 1" descr="8326871103225823980.jpg"/>
           <p:cNvPicPr>
             <a:picLocks noChangeAspect="1"/>
           </p:cNvPicPr>
@@ -6430,7 +6430,7 @@
       </p:sp>
       <p:pic>
         <p:nvPicPr>
-          <p:cNvPr id="5" name="Picture 4" descr="8012680534896129970.jpg"/>
+          <p:cNvPr id="5" name="Picture 4" descr="3142509436941722391.jpg"/>
           <p:cNvPicPr>
             <a:picLocks noChangeAspect="1"/>
           </p:cNvPicPr>
@@ -6641,7 +6641,7 @@
       <p:grpSpPr/>
       <p:pic>
         <p:nvPicPr>
-          <p:cNvPr id="2" name="Picture 1" descr="5708200061706211922.jpg"/>
+          <p:cNvPr id="2" name="Picture 1" descr="619130074955398364.jpg"/>
           <p:cNvPicPr>
             <a:picLocks noChangeAspect="1"/>
           </p:cNvPicPr>
@@ -6821,7 +6821,7 @@
       </p:sp>
       <p:pic>
         <p:nvPicPr>
-          <p:cNvPr id="7" name="Picture 6" descr="2907107169872498138.jpg"/>
+          <p:cNvPr id="7" name="Picture 6" descr="5272716654464923778.jpg"/>
           <p:cNvPicPr>
             <a:picLocks noChangeAspect="1"/>
           </p:cNvPicPr>
@@ -7018,7 +7018,7 @@
     <p:bg>
       <p:bgPr>
         <a:solidFill>
-          <a:srgbClr val="31662F"/>
+          <a:srgbClr val="F3F1EA"/>
         </a:solidFill>
         <a:effectLst/>
       </p:bgPr>
@@ -7060,7 +7060,7 @@
             <a:r>
               <a:rPr sz="5200" b="1" i="0">
                 <a:solidFill>
-                  <a:srgbClr val="F3F1EA"/>
+                  <a:srgbClr val="31662F"/>
                 </a:solidFill>
                 <a:latin typeface="Montserrat"/>
               </a:rPr>
@@ -7099,7 +7099,7 @@
             <a:r>
               <a:rPr sz="3000" b="0" i="1">
                 <a:solidFill>
-                  <a:srgbClr val="F3F1EA"/>
+                  <a:srgbClr val="1A1A1A"/>
                 </a:solidFill>
                 <a:latin typeface="EB Garamond"/>
               </a:rPr>
@@ -7206,7 +7206,7 @@
       </p:pic>
       <p:pic>
         <p:nvPicPr>
-          <p:cNvPr id="8" name="Picture 7" descr="foundation-logo-white.png"/>
+          <p:cNvPr id="8" name="Picture 7" descr="foundation-logo-color.png"/>
           <p:cNvPicPr>
             <a:picLocks noChangeAspect="1"/>
           </p:cNvPicPr>

</xml_diff>